<commit_message>
changed next trigram - MON
</commit_message>
<xml_diff>
--- a/view/mockups/design.pptx
+++ b/view/mockups/design.pptx
@@ -10,7 +10,8 @@
     <p:sldId id="259" r:id="rId4"/>
     <p:sldId id="260" r:id="rId5"/>
     <p:sldId id="262" r:id="rId6"/>
-    <p:sldId id="256" r:id="rId7"/>
+    <p:sldId id="263" r:id="rId7"/>
+    <p:sldId id="256" r:id="rId8"/>
   </p:sldIdLst>
   <p:sldSz cx="12192000" cy="6858000"/>
   <p:notesSz cx="6858000" cy="9144000"/>
@@ -264,7 +265,7 @@
           <a:p>
             <a:fld id="{41134A05-97AD-4E40-BF00-939D750435D9}" type="datetimeFigureOut">
               <a:rPr lang="en-US" smtClean="0"/>
-              <a:t>5/1/24</a:t>
+              <a:t>5/2/24</a:t>
             </a:fld>
             <a:endParaRPr lang="en-US"/>
           </a:p>
@@ -462,7 +463,7 @@
           <a:p>
             <a:fld id="{41134A05-97AD-4E40-BF00-939D750435D9}" type="datetimeFigureOut">
               <a:rPr lang="en-US" smtClean="0"/>
-              <a:t>5/1/24</a:t>
+              <a:t>5/2/24</a:t>
             </a:fld>
             <a:endParaRPr lang="en-US"/>
           </a:p>
@@ -670,7 +671,7 @@
           <a:p>
             <a:fld id="{41134A05-97AD-4E40-BF00-939D750435D9}" type="datetimeFigureOut">
               <a:rPr lang="en-US" smtClean="0"/>
-              <a:t>5/1/24</a:t>
+              <a:t>5/2/24</a:t>
             </a:fld>
             <a:endParaRPr lang="en-US"/>
           </a:p>
@@ -868,7 +869,7 @@
           <a:p>
             <a:fld id="{41134A05-97AD-4E40-BF00-939D750435D9}" type="datetimeFigureOut">
               <a:rPr lang="en-US" smtClean="0"/>
-              <a:t>5/1/24</a:t>
+              <a:t>5/2/24</a:t>
             </a:fld>
             <a:endParaRPr lang="en-US"/>
           </a:p>
@@ -1143,7 +1144,7 @@
           <a:p>
             <a:fld id="{41134A05-97AD-4E40-BF00-939D750435D9}" type="datetimeFigureOut">
               <a:rPr lang="en-US" smtClean="0"/>
-              <a:t>5/1/24</a:t>
+              <a:t>5/2/24</a:t>
             </a:fld>
             <a:endParaRPr lang="en-US"/>
           </a:p>
@@ -1408,7 +1409,7 @@
           <a:p>
             <a:fld id="{41134A05-97AD-4E40-BF00-939D750435D9}" type="datetimeFigureOut">
               <a:rPr lang="en-US" smtClean="0"/>
-              <a:t>5/1/24</a:t>
+              <a:t>5/2/24</a:t>
             </a:fld>
             <a:endParaRPr lang="en-US"/>
           </a:p>
@@ -1820,7 +1821,7 @@
           <a:p>
             <a:fld id="{41134A05-97AD-4E40-BF00-939D750435D9}" type="datetimeFigureOut">
               <a:rPr lang="en-US" smtClean="0"/>
-              <a:t>5/1/24</a:t>
+              <a:t>5/2/24</a:t>
             </a:fld>
             <a:endParaRPr lang="en-US"/>
           </a:p>
@@ -1961,7 +1962,7 @@
           <a:p>
             <a:fld id="{41134A05-97AD-4E40-BF00-939D750435D9}" type="datetimeFigureOut">
               <a:rPr lang="en-US" smtClean="0"/>
-              <a:t>5/1/24</a:t>
+              <a:t>5/2/24</a:t>
             </a:fld>
             <a:endParaRPr lang="en-US"/>
           </a:p>
@@ -2074,7 +2075,7 @@
           <a:p>
             <a:fld id="{41134A05-97AD-4E40-BF00-939D750435D9}" type="datetimeFigureOut">
               <a:rPr lang="en-US" smtClean="0"/>
-              <a:t>5/1/24</a:t>
+              <a:t>5/2/24</a:t>
             </a:fld>
             <a:endParaRPr lang="en-US"/>
           </a:p>
@@ -2385,7 +2386,7 @@
           <a:p>
             <a:fld id="{41134A05-97AD-4E40-BF00-939D750435D9}" type="datetimeFigureOut">
               <a:rPr lang="en-US" smtClean="0"/>
-              <a:t>5/1/24</a:t>
+              <a:t>5/2/24</a:t>
             </a:fld>
             <a:endParaRPr lang="en-US"/>
           </a:p>
@@ -2673,7 +2674,7 @@
           <a:p>
             <a:fld id="{41134A05-97AD-4E40-BF00-939D750435D9}" type="datetimeFigureOut">
               <a:rPr lang="en-US" smtClean="0"/>
-              <a:t>5/1/24</a:t>
+              <a:t>5/2/24</a:t>
             </a:fld>
             <a:endParaRPr lang="en-US"/>
           </a:p>
@@ -2914,7 +2915,7 @@
           <a:p>
             <a:fld id="{41134A05-97AD-4E40-BF00-939D750435D9}" type="datetimeFigureOut">
               <a:rPr lang="en-US" smtClean="0"/>
-              <a:t>5/1/24</a:t>
+              <a:t>5/2/24</a:t>
             </a:fld>
             <a:endParaRPr lang="en-US"/>
           </a:p>
@@ -29612,6 +29613,803 @@
     <p:bg>
       <p:bgPr>
         <a:solidFill>
+          <a:schemeClr val="tx1"/>
+        </a:solidFill>
+        <a:effectLst/>
+      </p:bgPr>
+    </p:bg>
+    <p:spTree>
+      <p:nvGrpSpPr>
+        <p:cNvPr id="1" name=""/>
+        <p:cNvGrpSpPr/>
+        <p:nvPr/>
+      </p:nvGrpSpPr>
+      <p:grpSpPr>
+        <a:xfrm>
+          <a:off x="0" y="0"/>
+          <a:ext cx="0" cy="0"/>
+          <a:chOff x="0" y="0"/>
+          <a:chExt cx="0" cy="0"/>
+        </a:xfrm>
+      </p:grpSpPr>
+      <p:pic>
+        <p:nvPicPr>
+          <p:cNvPr id="1026" name="Picture 2">
+            <a:extLst>
+              <a:ext uri="{FF2B5EF4-FFF2-40B4-BE49-F238E27FC236}">
+                <a16:creationId xmlns:a16="http://schemas.microsoft.com/office/drawing/2014/main" id="{7E09E2B9-C5D1-B42A-3CE2-A20D893FD14D}"/>
+              </a:ext>
+            </a:extLst>
+          </p:cNvPr>
+          <p:cNvPicPr>
+            <a:picLocks noChangeAspect="1" noChangeArrowheads="1"/>
+          </p:cNvPicPr>
+          <p:nvPr/>
+        </p:nvPicPr>
+        <p:blipFill rotWithShape="1">
+          <a:blip r:embed="rId2">
+            <a:extLst>
+              <a:ext uri="{28A0092B-C50C-407E-A947-70E740481C1C}">
+                <a14:useLocalDpi xmlns:a14="http://schemas.microsoft.com/office/drawing/2010/main" val="0"/>
+              </a:ext>
+            </a:extLst>
+          </a:blip>
+          <a:srcRect l="37170" t="21371" r="34748" b="67401"/>
+          <a:stretch/>
+        </p:blipFill>
+        <p:spPr bwMode="auto">
+          <a:xfrm>
+            <a:off x="6749716" y="529389"/>
+            <a:ext cx="3959142" cy="2815390"/>
+          </a:xfrm>
+          <a:prstGeom prst="rect">
+            <a:avLst/>
+          </a:prstGeom>
+          <a:noFill/>
+          <a:extLst>
+            <a:ext uri="{909E8E84-426E-40DD-AFC4-6F175D3DCCD1}">
+              <a14:hiddenFill xmlns:a14="http://schemas.microsoft.com/office/drawing/2010/main">
+                <a:solidFill>
+                  <a:srgbClr val="FFFFFF"/>
+                </a:solidFill>
+              </a14:hiddenFill>
+            </a:ext>
+          </a:extLst>
+        </p:spPr>
+      </p:pic>
+      <p:grpSp>
+        <p:nvGrpSpPr>
+          <p:cNvPr id="2" name="Group 1">
+            <a:extLst>
+              <a:ext uri="{FF2B5EF4-FFF2-40B4-BE49-F238E27FC236}">
+                <a16:creationId xmlns:a16="http://schemas.microsoft.com/office/drawing/2014/main" id="{BF9809DF-0389-0F2F-7587-6A6FF3E8956D}"/>
+              </a:ext>
+            </a:extLst>
+          </p:cNvPr>
+          <p:cNvGrpSpPr/>
+          <p:nvPr/>
+        </p:nvGrpSpPr>
+        <p:grpSpPr>
+          <a:xfrm>
+            <a:off x="2391333" y="2728343"/>
+            <a:ext cx="2717944" cy="1734534"/>
+            <a:chOff x="2391333" y="2728343"/>
+            <a:chExt cx="2717944" cy="1734534"/>
+          </a:xfrm>
+        </p:grpSpPr>
+        <p:sp>
+          <p:nvSpPr>
+            <p:cNvPr id="4" name="Rounded Rectangle 3">
+              <a:extLst>
+                <a:ext uri="{FF2B5EF4-FFF2-40B4-BE49-F238E27FC236}">
+                  <a16:creationId xmlns:a16="http://schemas.microsoft.com/office/drawing/2014/main" id="{4359527B-9C60-EAE5-0182-0EF972D9C40D}"/>
+                </a:ext>
+              </a:extLst>
+            </p:cNvPr>
+            <p:cNvSpPr/>
+            <p:nvPr/>
+          </p:nvSpPr>
+          <p:spPr>
+            <a:xfrm>
+              <a:off x="4146752" y="3067212"/>
+              <a:ext cx="962525" cy="1395665"/>
+            </a:xfrm>
+            <a:prstGeom prst="roundRect">
+              <a:avLst>
+                <a:gd name="adj" fmla="val 10417"/>
+              </a:avLst>
+            </a:prstGeom>
+            <a:solidFill>
+              <a:schemeClr val="bg1"/>
+            </a:solidFill>
+            <a:ln>
+              <a:noFill/>
+            </a:ln>
+          </p:spPr>
+          <p:style>
+            <a:lnRef idx="2">
+              <a:schemeClr val="accent1">
+                <a:shade val="15000"/>
+              </a:schemeClr>
+            </a:lnRef>
+            <a:fillRef idx="1">
+              <a:schemeClr val="accent1"/>
+            </a:fillRef>
+            <a:effectRef idx="0">
+              <a:schemeClr val="accent1"/>
+            </a:effectRef>
+            <a:fontRef idx="minor">
+              <a:schemeClr val="lt1"/>
+            </a:fontRef>
+          </p:style>
+          <p:txBody>
+            <a:bodyPr rtlCol="0" anchor="ctr"/>
+            <a:lstStyle/>
+            <a:p>
+              <a:pPr algn="ctr"/>
+              <a:endParaRPr lang="en-US"/>
+            </a:p>
+          </p:txBody>
+        </p:sp>
+        <p:sp>
+          <p:nvSpPr>
+            <p:cNvPr id="6" name="Rounded Rectangle 5">
+              <a:extLst>
+                <a:ext uri="{FF2B5EF4-FFF2-40B4-BE49-F238E27FC236}">
+                  <a16:creationId xmlns:a16="http://schemas.microsoft.com/office/drawing/2014/main" id="{FE20EE09-5561-D575-C1CE-6E3C03A73145}"/>
+                </a:ext>
+              </a:extLst>
+            </p:cNvPr>
+            <p:cNvSpPr/>
+            <p:nvPr/>
+          </p:nvSpPr>
+          <p:spPr>
+            <a:xfrm>
+              <a:off x="4226963" y="3139403"/>
+              <a:ext cx="798094" cy="1106906"/>
+            </a:xfrm>
+            <a:prstGeom prst="roundRect">
+              <a:avLst>
+                <a:gd name="adj" fmla="val 4167"/>
+              </a:avLst>
+            </a:prstGeom>
+            <a:solidFill>
+              <a:schemeClr val="tx1"/>
+            </a:solidFill>
+            <a:ln>
+              <a:noFill/>
+            </a:ln>
+          </p:spPr>
+          <p:style>
+            <a:lnRef idx="2">
+              <a:schemeClr val="accent1">
+                <a:shade val="15000"/>
+              </a:schemeClr>
+            </a:lnRef>
+            <a:fillRef idx="1">
+              <a:schemeClr val="accent1"/>
+            </a:fillRef>
+            <a:effectRef idx="0">
+              <a:schemeClr val="accent1"/>
+            </a:effectRef>
+            <a:fontRef idx="minor">
+              <a:schemeClr val="lt1"/>
+            </a:fontRef>
+          </p:style>
+          <p:txBody>
+            <a:bodyPr rtlCol="0" anchor="ctr"/>
+            <a:lstStyle/>
+            <a:p>
+              <a:pPr algn="ctr"/>
+              <a:endParaRPr lang="en-US"/>
+            </a:p>
+          </p:txBody>
+        </p:sp>
+        <p:sp>
+          <p:nvSpPr>
+            <p:cNvPr id="7" name="Oval 6">
+              <a:extLst>
+                <a:ext uri="{FF2B5EF4-FFF2-40B4-BE49-F238E27FC236}">
+                  <a16:creationId xmlns:a16="http://schemas.microsoft.com/office/drawing/2014/main" id="{6D5C3BA6-D49F-B5E2-20C1-8D195A792C0F}"/>
+                </a:ext>
+              </a:extLst>
+            </p:cNvPr>
+            <p:cNvSpPr/>
+            <p:nvPr/>
+          </p:nvSpPr>
+          <p:spPr>
+            <a:xfrm>
+              <a:off x="4580290" y="4308873"/>
+              <a:ext cx="91440" cy="91440"/>
+            </a:xfrm>
+            <a:prstGeom prst="ellipse">
+              <a:avLst/>
+            </a:prstGeom>
+            <a:solidFill>
+              <a:schemeClr val="tx1"/>
+            </a:solidFill>
+            <a:ln>
+              <a:noFill/>
+            </a:ln>
+          </p:spPr>
+          <p:style>
+            <a:lnRef idx="2">
+              <a:schemeClr val="accent1">
+                <a:shade val="15000"/>
+              </a:schemeClr>
+            </a:lnRef>
+            <a:fillRef idx="1">
+              <a:schemeClr val="accent1"/>
+            </a:fillRef>
+            <a:effectRef idx="0">
+              <a:schemeClr val="accent1"/>
+            </a:effectRef>
+            <a:fontRef idx="minor">
+              <a:schemeClr val="lt1"/>
+            </a:fontRef>
+          </p:style>
+          <p:txBody>
+            <a:bodyPr rtlCol="0" anchor="ctr"/>
+            <a:lstStyle/>
+            <a:p>
+              <a:pPr algn="ctr"/>
+              <a:endParaRPr lang="en-US"/>
+            </a:p>
+          </p:txBody>
+        </p:sp>
+        <p:sp>
+          <p:nvSpPr>
+            <p:cNvPr id="8" name="Oval 7">
+              <a:extLst>
+                <a:ext uri="{FF2B5EF4-FFF2-40B4-BE49-F238E27FC236}">
+                  <a16:creationId xmlns:a16="http://schemas.microsoft.com/office/drawing/2014/main" id="{153DC482-AF34-28C2-20CB-703F02B9A55C}"/>
+                </a:ext>
+              </a:extLst>
+            </p:cNvPr>
+            <p:cNvSpPr/>
+            <p:nvPr/>
+          </p:nvSpPr>
+          <p:spPr>
+            <a:xfrm>
+              <a:off x="4745425" y="3479041"/>
+              <a:ext cx="91440" cy="91440"/>
+            </a:xfrm>
+            <a:prstGeom prst="ellipse">
+              <a:avLst/>
+            </a:prstGeom>
+            <a:solidFill>
+              <a:schemeClr val="bg1"/>
+            </a:solidFill>
+            <a:ln>
+              <a:noFill/>
+            </a:ln>
+          </p:spPr>
+          <p:style>
+            <a:lnRef idx="2">
+              <a:schemeClr val="accent1">
+                <a:shade val="15000"/>
+              </a:schemeClr>
+            </a:lnRef>
+            <a:fillRef idx="1">
+              <a:schemeClr val="accent1"/>
+            </a:fillRef>
+            <a:effectRef idx="0">
+              <a:schemeClr val="accent1"/>
+            </a:effectRef>
+            <a:fontRef idx="minor">
+              <a:schemeClr val="lt1"/>
+            </a:fontRef>
+          </p:style>
+          <p:txBody>
+            <a:bodyPr rtlCol="0" anchor="ctr"/>
+            <a:lstStyle/>
+            <a:p>
+              <a:pPr algn="ctr"/>
+              <a:endParaRPr lang="en-US"/>
+            </a:p>
+          </p:txBody>
+        </p:sp>
+        <p:sp>
+          <p:nvSpPr>
+            <p:cNvPr id="10" name="Oval 9">
+              <a:extLst>
+                <a:ext uri="{FF2B5EF4-FFF2-40B4-BE49-F238E27FC236}">
+                  <a16:creationId xmlns:a16="http://schemas.microsoft.com/office/drawing/2014/main" id="{C7814448-2387-D0FD-14E5-86BF68C611A2}"/>
+                </a:ext>
+              </a:extLst>
+            </p:cNvPr>
+            <p:cNvSpPr/>
+            <p:nvPr/>
+          </p:nvSpPr>
+          <p:spPr>
+            <a:xfrm>
+              <a:off x="4451360" y="3479041"/>
+              <a:ext cx="91440" cy="91440"/>
+            </a:xfrm>
+            <a:prstGeom prst="ellipse">
+              <a:avLst/>
+            </a:prstGeom>
+            <a:solidFill>
+              <a:schemeClr val="bg1"/>
+            </a:solidFill>
+            <a:ln>
+              <a:noFill/>
+            </a:ln>
+          </p:spPr>
+          <p:style>
+            <a:lnRef idx="2">
+              <a:schemeClr val="accent1">
+                <a:shade val="15000"/>
+              </a:schemeClr>
+            </a:lnRef>
+            <a:fillRef idx="1">
+              <a:schemeClr val="accent1"/>
+            </a:fillRef>
+            <a:effectRef idx="0">
+              <a:schemeClr val="accent1"/>
+            </a:effectRef>
+            <a:fontRef idx="minor">
+              <a:schemeClr val="lt1"/>
+            </a:fontRef>
+          </p:style>
+          <p:txBody>
+            <a:bodyPr rtlCol="0" anchor="ctr"/>
+            <a:lstStyle/>
+            <a:p>
+              <a:pPr algn="ctr"/>
+              <a:endParaRPr lang="en-US"/>
+            </a:p>
+          </p:txBody>
+        </p:sp>
+        <p:sp>
+          <p:nvSpPr>
+            <p:cNvPr id="11" name="Block Arc 10">
+              <a:extLst>
+                <a:ext uri="{FF2B5EF4-FFF2-40B4-BE49-F238E27FC236}">
+                  <a16:creationId xmlns:a16="http://schemas.microsoft.com/office/drawing/2014/main" id="{93A09BBF-E27A-23B5-EB47-C3821DE30565}"/>
+                </a:ext>
+              </a:extLst>
+            </p:cNvPr>
+            <p:cNvSpPr/>
+            <p:nvPr/>
+          </p:nvSpPr>
+          <p:spPr>
+            <a:xfrm rot="10800000">
+              <a:off x="4420978" y="3524761"/>
+              <a:ext cx="453607" cy="413869"/>
+            </a:xfrm>
+            <a:prstGeom prst="blockArc">
+              <a:avLst>
+                <a:gd name="adj1" fmla="val 11013671"/>
+                <a:gd name="adj2" fmla="val 21316100"/>
+                <a:gd name="adj3" fmla="val 12596"/>
+              </a:avLst>
+            </a:prstGeom>
+            <a:solidFill>
+              <a:schemeClr val="bg1"/>
+            </a:solidFill>
+            <a:ln>
+              <a:noFill/>
+            </a:ln>
+          </p:spPr>
+          <p:style>
+            <a:lnRef idx="2">
+              <a:schemeClr val="accent1">
+                <a:shade val="15000"/>
+              </a:schemeClr>
+            </a:lnRef>
+            <a:fillRef idx="1">
+              <a:schemeClr val="accent1"/>
+            </a:fillRef>
+            <a:effectRef idx="0">
+              <a:schemeClr val="accent1"/>
+            </a:effectRef>
+            <a:fontRef idx="minor">
+              <a:schemeClr val="lt1"/>
+            </a:fontRef>
+          </p:style>
+          <p:txBody>
+            <a:bodyPr rtlCol="0" anchor="ctr"/>
+            <a:lstStyle/>
+            <a:p>
+              <a:pPr algn="ctr"/>
+              <a:endParaRPr lang="en-US">
+                <a:solidFill>
+                  <a:schemeClr val="tx1"/>
+                </a:solidFill>
+              </a:endParaRPr>
+            </a:p>
+          </p:txBody>
+        </p:sp>
+        <p:sp>
+          <p:nvSpPr>
+            <p:cNvPr id="18" name="Rounded Rectangle 17">
+              <a:extLst>
+                <a:ext uri="{FF2B5EF4-FFF2-40B4-BE49-F238E27FC236}">
+                  <a16:creationId xmlns:a16="http://schemas.microsoft.com/office/drawing/2014/main" id="{3CED7246-76E8-982D-649D-035D714B878B}"/>
+                </a:ext>
+              </a:extLst>
+            </p:cNvPr>
+            <p:cNvSpPr/>
+            <p:nvPr/>
+          </p:nvSpPr>
+          <p:spPr>
+            <a:xfrm rot="16200000">
+              <a:off x="2607903" y="3283782"/>
+              <a:ext cx="962525" cy="1395665"/>
+            </a:xfrm>
+            <a:prstGeom prst="roundRect">
+              <a:avLst>
+                <a:gd name="adj" fmla="val 10417"/>
+              </a:avLst>
+            </a:prstGeom>
+            <a:solidFill>
+              <a:schemeClr val="bg1"/>
+            </a:solidFill>
+            <a:ln>
+              <a:noFill/>
+            </a:ln>
+          </p:spPr>
+          <p:style>
+            <a:lnRef idx="2">
+              <a:schemeClr val="accent1">
+                <a:shade val="15000"/>
+              </a:schemeClr>
+            </a:lnRef>
+            <a:fillRef idx="1">
+              <a:schemeClr val="accent1"/>
+            </a:fillRef>
+            <a:effectRef idx="0">
+              <a:schemeClr val="accent1"/>
+            </a:effectRef>
+            <a:fontRef idx="minor">
+              <a:schemeClr val="lt1"/>
+            </a:fontRef>
+          </p:style>
+          <p:txBody>
+            <a:bodyPr rtlCol="0" anchor="ctr"/>
+            <a:lstStyle/>
+            <a:p>
+              <a:pPr algn="ctr"/>
+              <a:endParaRPr lang="en-US"/>
+            </a:p>
+          </p:txBody>
+        </p:sp>
+        <p:sp>
+          <p:nvSpPr>
+            <p:cNvPr id="19" name="Rounded Rectangle 18">
+              <a:extLst>
+                <a:ext uri="{FF2B5EF4-FFF2-40B4-BE49-F238E27FC236}">
+                  <a16:creationId xmlns:a16="http://schemas.microsoft.com/office/drawing/2014/main" id="{7029960D-EB78-1FD5-45B6-41F1EA57AC59}"/>
+                </a:ext>
+              </a:extLst>
+            </p:cNvPr>
+            <p:cNvSpPr/>
+            <p:nvPr/>
+          </p:nvSpPr>
+          <p:spPr>
+            <a:xfrm rot="16200000">
+              <a:off x="2617930" y="3430166"/>
+              <a:ext cx="798094" cy="1106906"/>
+            </a:xfrm>
+            <a:prstGeom prst="roundRect">
+              <a:avLst>
+                <a:gd name="adj" fmla="val 4167"/>
+              </a:avLst>
+            </a:prstGeom>
+            <a:solidFill>
+              <a:schemeClr val="tx1"/>
+            </a:solidFill>
+            <a:ln>
+              <a:noFill/>
+            </a:ln>
+          </p:spPr>
+          <p:style>
+            <a:lnRef idx="2">
+              <a:schemeClr val="accent1">
+                <a:shade val="15000"/>
+              </a:schemeClr>
+            </a:lnRef>
+            <a:fillRef idx="1">
+              <a:schemeClr val="accent1"/>
+            </a:fillRef>
+            <a:effectRef idx="0">
+              <a:schemeClr val="accent1"/>
+            </a:effectRef>
+            <a:fontRef idx="minor">
+              <a:schemeClr val="lt1"/>
+            </a:fontRef>
+          </p:style>
+          <p:txBody>
+            <a:bodyPr rtlCol="0" anchor="ctr"/>
+            <a:lstStyle/>
+            <a:p>
+              <a:pPr algn="ctr"/>
+              <a:endParaRPr lang="en-US" dirty="0"/>
+            </a:p>
+          </p:txBody>
+        </p:sp>
+        <p:sp>
+          <p:nvSpPr>
+            <p:cNvPr id="20" name="Oval 19">
+              <a:extLst>
+                <a:ext uri="{FF2B5EF4-FFF2-40B4-BE49-F238E27FC236}">
+                  <a16:creationId xmlns:a16="http://schemas.microsoft.com/office/drawing/2014/main" id="{83693644-8712-AC2A-CFD5-9B54C66DAEBE}"/>
+                </a:ext>
+              </a:extLst>
+            </p:cNvPr>
+            <p:cNvSpPr/>
+            <p:nvPr/>
+          </p:nvSpPr>
+          <p:spPr>
+            <a:xfrm rot="16200000">
+              <a:off x="3632994" y="3937899"/>
+              <a:ext cx="91440" cy="91440"/>
+            </a:xfrm>
+            <a:prstGeom prst="ellipse">
+              <a:avLst/>
+            </a:prstGeom>
+            <a:solidFill>
+              <a:schemeClr val="tx1"/>
+            </a:solidFill>
+            <a:ln>
+              <a:noFill/>
+            </a:ln>
+          </p:spPr>
+          <p:style>
+            <a:lnRef idx="2">
+              <a:schemeClr val="accent1">
+                <a:shade val="15000"/>
+              </a:schemeClr>
+            </a:lnRef>
+            <a:fillRef idx="1">
+              <a:schemeClr val="accent1"/>
+            </a:fillRef>
+            <a:effectRef idx="0">
+              <a:schemeClr val="accent1"/>
+            </a:effectRef>
+            <a:fontRef idx="minor">
+              <a:schemeClr val="lt1"/>
+            </a:fontRef>
+          </p:style>
+          <p:txBody>
+            <a:bodyPr rtlCol="0" anchor="ctr"/>
+            <a:lstStyle/>
+            <a:p>
+              <a:pPr algn="ctr"/>
+              <a:endParaRPr lang="en-US"/>
+            </a:p>
+          </p:txBody>
+        </p:sp>
+        <p:sp>
+          <p:nvSpPr>
+            <p:cNvPr id="15" name="Oval 14">
+              <a:extLst>
+                <a:ext uri="{FF2B5EF4-FFF2-40B4-BE49-F238E27FC236}">
+                  <a16:creationId xmlns:a16="http://schemas.microsoft.com/office/drawing/2014/main" id="{845D1CFE-0441-7C22-A6C5-74B9F33FE503}"/>
+                </a:ext>
+              </a:extLst>
+            </p:cNvPr>
+            <p:cNvSpPr/>
+            <p:nvPr/>
+          </p:nvSpPr>
+          <p:spPr>
+            <a:xfrm rot="16200000">
+              <a:off x="2803162" y="3794536"/>
+              <a:ext cx="91440" cy="91440"/>
+            </a:xfrm>
+            <a:prstGeom prst="ellipse">
+              <a:avLst/>
+            </a:prstGeom>
+            <a:solidFill>
+              <a:schemeClr val="bg1"/>
+            </a:solidFill>
+            <a:ln>
+              <a:noFill/>
+            </a:ln>
+          </p:spPr>
+          <p:style>
+            <a:lnRef idx="2">
+              <a:schemeClr val="accent1">
+                <a:shade val="15000"/>
+              </a:schemeClr>
+            </a:lnRef>
+            <a:fillRef idx="1">
+              <a:schemeClr val="accent1"/>
+            </a:fillRef>
+            <a:effectRef idx="0">
+              <a:schemeClr val="accent1"/>
+            </a:effectRef>
+            <a:fontRef idx="minor">
+              <a:schemeClr val="lt1"/>
+            </a:fontRef>
+          </p:style>
+          <p:txBody>
+            <a:bodyPr rtlCol="0" anchor="ctr"/>
+            <a:lstStyle/>
+            <a:p>
+              <a:pPr algn="ctr"/>
+              <a:endParaRPr lang="en-US"/>
+            </a:p>
+          </p:txBody>
+        </p:sp>
+        <p:sp>
+          <p:nvSpPr>
+            <p:cNvPr id="16" name="Oval 15">
+              <a:extLst>
+                <a:ext uri="{FF2B5EF4-FFF2-40B4-BE49-F238E27FC236}">
+                  <a16:creationId xmlns:a16="http://schemas.microsoft.com/office/drawing/2014/main" id="{FFC504B5-A4F0-1557-3C94-2067AB0BE018}"/>
+                </a:ext>
+              </a:extLst>
+            </p:cNvPr>
+            <p:cNvSpPr/>
+            <p:nvPr/>
+          </p:nvSpPr>
+          <p:spPr>
+            <a:xfrm rot="16200000">
+              <a:off x="2803162" y="4088601"/>
+              <a:ext cx="91440" cy="91440"/>
+            </a:xfrm>
+            <a:prstGeom prst="ellipse">
+              <a:avLst/>
+            </a:prstGeom>
+            <a:solidFill>
+              <a:schemeClr val="bg1"/>
+            </a:solidFill>
+            <a:ln>
+              <a:noFill/>
+            </a:ln>
+          </p:spPr>
+          <p:style>
+            <a:lnRef idx="2">
+              <a:schemeClr val="accent1">
+                <a:shade val="15000"/>
+              </a:schemeClr>
+            </a:lnRef>
+            <a:fillRef idx="1">
+              <a:schemeClr val="accent1"/>
+            </a:fillRef>
+            <a:effectRef idx="0">
+              <a:schemeClr val="accent1"/>
+            </a:effectRef>
+            <a:fontRef idx="minor">
+              <a:schemeClr val="lt1"/>
+            </a:fontRef>
+          </p:style>
+          <p:txBody>
+            <a:bodyPr rtlCol="0" anchor="ctr"/>
+            <a:lstStyle/>
+            <a:p>
+              <a:pPr algn="ctr"/>
+              <a:endParaRPr lang="en-US"/>
+            </a:p>
+          </p:txBody>
+        </p:sp>
+        <p:cxnSp>
+          <p:nvCxnSpPr>
+            <p:cNvPr id="22" name="Straight Connector 21">
+              <a:extLst>
+                <a:ext uri="{FF2B5EF4-FFF2-40B4-BE49-F238E27FC236}">
+                  <a16:creationId xmlns:a16="http://schemas.microsoft.com/office/drawing/2014/main" id="{FFC528AF-9C63-1A25-6CF0-B9C5C09377E0}"/>
+                </a:ext>
+              </a:extLst>
+            </p:cNvPr>
+            <p:cNvCxnSpPr>
+              <a:cxnSpLocks/>
+            </p:cNvCxnSpPr>
+            <p:nvPr/>
+          </p:nvCxnSpPr>
+          <p:spPr>
+            <a:xfrm flipV="1">
+              <a:off x="3071446" y="3784911"/>
+              <a:ext cx="103212" cy="415887"/>
+            </a:xfrm>
+            <a:prstGeom prst="line">
+              <a:avLst/>
+            </a:prstGeom>
+            <a:ln w="44450">
+              <a:solidFill>
+                <a:schemeClr val="bg1"/>
+              </a:solidFill>
+            </a:ln>
+          </p:spPr>
+          <p:style>
+            <a:lnRef idx="1">
+              <a:schemeClr val="accent1"/>
+            </a:lnRef>
+            <a:fillRef idx="0">
+              <a:schemeClr val="accent1"/>
+            </a:fillRef>
+            <a:effectRef idx="0">
+              <a:schemeClr val="accent1"/>
+            </a:effectRef>
+            <a:fontRef idx="minor">
+              <a:schemeClr val="tx1"/>
+            </a:fontRef>
+          </p:style>
+        </p:cxnSp>
+        <p:sp>
+          <p:nvSpPr>
+            <p:cNvPr id="24" name="Circular Arrow 23">
+              <a:extLst>
+                <a:ext uri="{FF2B5EF4-FFF2-40B4-BE49-F238E27FC236}">
+                  <a16:creationId xmlns:a16="http://schemas.microsoft.com/office/drawing/2014/main" id="{D8F6094B-C913-AA21-C6B5-8ADAD1A7A23A}"/>
+                </a:ext>
+              </a:extLst>
+            </p:cNvPr>
+            <p:cNvSpPr/>
+            <p:nvPr/>
+          </p:nvSpPr>
+          <p:spPr>
+            <a:xfrm>
+              <a:off x="3424519" y="2728343"/>
+              <a:ext cx="709240" cy="700657"/>
+            </a:xfrm>
+            <a:prstGeom prst="circularArrow">
+              <a:avLst>
+                <a:gd name="adj1" fmla="val 7817"/>
+                <a:gd name="adj2" fmla="val 1213249"/>
+                <a:gd name="adj3" fmla="val 20121824"/>
+                <a:gd name="adj4" fmla="val 5784138"/>
+                <a:gd name="adj5" fmla="val 13410"/>
+              </a:avLst>
+            </a:prstGeom>
+            <a:solidFill>
+              <a:schemeClr val="bg1"/>
+            </a:solidFill>
+            <a:ln>
+              <a:noFill/>
+            </a:ln>
+          </p:spPr>
+          <p:style>
+            <a:lnRef idx="2">
+              <a:schemeClr val="accent1">
+                <a:shade val="15000"/>
+              </a:schemeClr>
+            </a:lnRef>
+            <a:fillRef idx="1">
+              <a:schemeClr val="accent1"/>
+            </a:fillRef>
+            <a:effectRef idx="0">
+              <a:schemeClr val="accent1"/>
+            </a:effectRef>
+            <a:fontRef idx="minor">
+              <a:schemeClr val="lt1"/>
+            </a:fontRef>
+          </p:style>
+          <p:txBody>
+            <a:bodyPr rtlCol="0" anchor="ctr"/>
+            <a:lstStyle/>
+            <a:p>
+              <a:pPr algn="ctr"/>
+              <a:endParaRPr lang="en-US">
+                <a:solidFill>
+                  <a:schemeClr val="tx1"/>
+                </a:solidFill>
+              </a:endParaRPr>
+            </a:p>
+          </p:txBody>
+        </p:sp>
+      </p:grpSp>
+    </p:spTree>
+    <p:extLst>
+      <p:ext uri="{BB962C8B-B14F-4D97-AF65-F5344CB8AC3E}">
+        <p14:creationId xmlns:p14="http://schemas.microsoft.com/office/powerpoint/2010/main" val="3583248965"/>
+      </p:ext>
+    </p:extLst>
+  </p:cSld>
+  <p:clrMapOvr>
+    <a:masterClrMapping/>
+  </p:clrMapOvr>
+</p:sld>
+</file>
+
+<file path=ppt/slides/slide7.xml><?xml version="1.0" encoding="utf-8"?>
+<p:sld xmlns:a="http://schemas.openxmlformats.org/drawingml/2006/main" xmlns:r="http://schemas.openxmlformats.org/officeDocument/2006/relationships" xmlns:p="http://schemas.openxmlformats.org/presentationml/2006/main">
+  <p:cSld>
+    <p:bg>
+      <p:bgPr>
+        <a:solidFill>
           <a:schemeClr val="bg2"/>
         </a:solidFill>
         <a:effectLst/>

</xml_diff>